<commit_message>
: Déploiement : GitHub Pages activé, README finalisé et présentation PowerPoint ajoutée
</commit_message>
<xml_diff>
--- a/Dolores Mav L1CS Presentation.pptx
+++ b/Dolores Mav L1CS Presentation.pptx
@@ -2196,8 +2196,8 @@
         </p:nvSpPr>
         <p:spPr>
           <a:xfrm>
-            <a:off x="789783" y="3140650"/>
-            <a:ext cx="4114800" cy="438912"/>
+            <a:off x="789782" y="3140650"/>
+            <a:ext cx="6128907" cy="438912"/>
           </a:xfrm>
           <a:prstGeom prst="rect">
             <a:avLst/>
@@ -2221,6 +2221,12 @@
                 <a:cs typeface="Calibri" pitchFamily="34" charset="-120"/>
               </a:rPr>
               <a:t>Lien :</a:t>
+            </a:r>
+            <a:r>
+              <a:rPr lang="fr-FR" b="1" u="sng" dirty="0">
+                <a:hlinkClick r:id="rId3"/>
+              </a:rPr>
+              <a:t>https://tdmds06.github.io/Dolores-Mav-AfriTalent/</a:t>
             </a:r>
             <a:endParaRPr lang="fr-FR" sz="1400" b="0" dirty="0">
               <a:solidFill>
@@ -7557,7 +7563,7 @@
         </p:nvSpPr>
         <p:spPr>
           <a:xfrm>
-            <a:off x="700709" y="531827"/>
+            <a:off x="0" y="0"/>
             <a:ext cx="9144000" cy="5143500"/>
           </a:xfrm>
           <a:prstGeom prst="rect">
@@ -8001,9 +8007,7 @@
             </a:schemeClr>
           </a:solidFill>
           <a:ln w="12700">
-            <a:solidFill>
-              <a:srgbClr val="1B6B72"/>
-            </a:solidFill>
+            <a:noFill/>
             <a:prstDash val="solid"/>
           </a:ln>
         </p:spPr>

</xml_diff>